<commit_message>
Prévia do custo por hora calculada no servidor (rota /empresa/custos/previa)
A tela de Empresa não repete mais a fórmula salário × fator ÷ horas: pede a
prévia ao SimularCustoHoraService, que usa a CalculadoraPrejuizo e os padrões
do Model Empresa. Testes, README, auditoria e slides atualizados (187 testes).

Co-Authored-By: Claude Opus 5.5 <noreply@anthropic.com>
</commit_message>
<xml_diff>
--- a/apresentacao/EdgeHealth_Apresentacao_Final.pptx
+++ b/apresentacao/EdgeHealth_Apresentacao_Final.pptx
@@ -1067,7 +1067,7 @@
           </a:p>
           <a:p>
             <a:r>
-              <a:t>Sobre qualidade: são 186 testes automatizados no backend e 20 no frontend, todos passando.</a:t>
+              <a:t>Sobre qualidade: são 187 testes automatizados no backend e 20 no frontend, todos passando.</a:t>
             </a:r>
           </a:p>
           <a:p>
@@ -9052,7 +9052,7 @@
                 </a:solidFill>
                 <a:latin typeface="Segoe UI"/>
               </a:rPr>
-              <a:t>186 testes no backend e 20 no frontend, todos passando.</a:t>
+              <a:t>187 testes no backend e 20 no frontend, todos passando.</a:t>
             </a:r>
           </a:p>
           <a:p>

</xml_diff>